<commit_message>
Remove custom backend and use public API only
</commit_message>
<xml_diff>
--- a/Hari_2_Flutter_Professional.pptx
+++ b/Hari_2_Flutter_Professional.pptx
@@ -21148,7 +21148,7 @@
               <a:rPr>
                 <a:latin typeface="Aptos"/>
               </a:rPr>
-              <a:t>•  Milik tool/backend</a:t>
+              <a:t>•  Milik tool developer</a:t>
             </a:r>
           </a:p>
           <a:p>
@@ -37235,7 +37235,7 @@
                         </a:defRPr>
                       </a:pPr>
                       <a:r>
-                        <a:t>Backend secret manager</a:t>
+                        <a:t>Runtime AI production</a:t>
                       </a:r>
                     </a:p>
                   </a:txBody>
@@ -37259,7 +37259,7 @@
                         </a:defRPr>
                       </a:pPr>
                       <a:r>
-                        <a:t>Ya untuk runtime</a:t>
+                        <a:t>Di luar scope</a:t>
                       </a:r>
                     </a:p>
                   </a:txBody>
@@ -37283,7 +37283,7 @@
                         </a:defRPr>
                       </a:pPr>
                       <a:r>
-                        <a:t>Proxy + auth + quota</a:t>
+                        <a:t>Butuh arsitektur terpisah</a:t>
                       </a:r>
                     </a:p>
                   </a:txBody>

</xml_diff>